<commit_message>
Slides: badged PPTX of sd-04-044
</commit_message>
<xml_diff>
--- a/system-design-101/vi/lessons/sd-04-044/slides/sd-04-044.pptx
+++ b/system-design-101/vi/lessons/sd-04-044/slides/sd-04-044.pptx
@@ -13188,7 +13188,7 @@
             <a:r>
               <a:rPr lang="en-US" sz="1950" b="1" spc="198" kern="0" dirty="0">
                 <a:solidFill>
-                  <a:srgbClr val="FF6A4D"/>
+                  <a:srgbClr val="3DD6A0"/>
                 </a:solidFill>
                 <a:latin typeface="Be Vietnam Pro" pitchFamily="34" charset="0"/>
                 <a:ea typeface="Be Vietnam Pro" pitchFamily="34" charset="-122"/>
@@ -13199,7 +13199,7 @@
             <a:r>
               <a:rPr lang="en-US" sz="1950" b="1" spc="227" kern="0" dirty="0">
                 <a:solidFill>
-                  <a:srgbClr val="FF6A4D"/>
+                  <a:srgbClr val="3DD6A0"/>
                 </a:solidFill>
                 <a:latin typeface="Be Vietnam Pro" pitchFamily="34" charset="0"/>
                 <a:ea typeface="Be Vietnam Pro" pitchFamily="34" charset="-122"/>
@@ -13210,7 +13210,7 @@
             <a:r>
               <a:rPr lang="en-US" sz="1950" b="1" spc="222" kern="0" dirty="0">
                 <a:solidFill>
-                  <a:srgbClr val="FF6A4D"/>
+                  <a:srgbClr val="3DD6A0"/>
                 </a:solidFill>
                 <a:latin typeface="Be Vietnam Pro" pitchFamily="34" charset="0"/>
                 <a:ea typeface="Be Vietnam Pro" pitchFamily="34" charset="-122"/>
@@ -13221,7 +13221,7 @@
             <a:r>
               <a:rPr lang="en-US" sz="1950" b="1" spc="225" kern="0" dirty="0">
                 <a:solidFill>
-                  <a:srgbClr val="FF6A4D"/>
+                  <a:srgbClr val="3DD6A0"/>
                 </a:solidFill>
                 <a:latin typeface="Be Vietnam Pro" pitchFamily="34" charset="0"/>
                 <a:ea typeface="Be Vietnam Pro" pitchFamily="34" charset="-122"/>
@@ -13232,7 +13232,7 @@
             <a:r>
               <a:rPr lang="en-US" sz="1950" b="1" spc="222" kern="0" dirty="0">
                 <a:solidFill>
-                  <a:srgbClr val="FF6A4D"/>
+                  <a:srgbClr val="3DD6A0"/>
                 </a:solidFill>
                 <a:latin typeface="Be Vietnam Pro" pitchFamily="34" charset="0"/>
                 <a:ea typeface="Be Vietnam Pro" pitchFamily="34" charset="-122"/>
@@ -13243,7 +13243,7 @@
             <a:r>
               <a:rPr lang="en-US" sz="1950" b="1" spc="228" kern="0" dirty="0">
                 <a:solidFill>
-                  <a:srgbClr val="FF6A4D"/>
+                  <a:srgbClr val="3DD6A0"/>
                 </a:solidFill>
                 <a:latin typeface="Be Vietnam Pro" pitchFamily="34" charset="0"/>
                 <a:ea typeface="Be Vietnam Pro" pitchFamily="34" charset="-122"/>
@@ -13254,7 +13254,7 @@
             <a:r>
               <a:rPr lang="en-US" sz="1950" b="1" spc="225" kern="0" dirty="0">
                 <a:solidFill>
-                  <a:srgbClr val="FF6A4D"/>
+                  <a:srgbClr val="3DD6A0"/>
                 </a:solidFill>
                 <a:latin typeface="Be Vietnam Pro" pitchFamily="34" charset="0"/>
                 <a:ea typeface="Be Vietnam Pro" pitchFamily="34" charset="-122"/>
@@ -13265,7 +13265,7 @@
             <a:r>
               <a:rPr lang="en-US" sz="1950" b="1" spc="226" kern="0" dirty="0">
                 <a:solidFill>
-                  <a:srgbClr val="FF6A4D"/>
+                  <a:srgbClr val="3DD6A0"/>
                 </a:solidFill>
                 <a:latin typeface="Be Vietnam Pro" pitchFamily="34" charset="0"/>
                 <a:ea typeface="Be Vietnam Pro" pitchFamily="34" charset="-122"/>
@@ -13276,7 +13276,7 @@
             <a:r>
               <a:rPr lang="en-US" sz="1950" b="1" spc="223" kern="0" dirty="0">
                 <a:solidFill>
-                  <a:srgbClr val="FF6A4D"/>
+                  <a:srgbClr val="3DD6A0"/>
                 </a:solidFill>
                 <a:latin typeface="Be Vietnam Pro" pitchFamily="34" charset="0"/>
                 <a:ea typeface="Be Vietnam Pro" pitchFamily="34" charset="-122"/>
@@ -13287,7 +13287,7 @@
             <a:r>
               <a:rPr lang="en-US" sz="1950" b="1" spc="205" kern="0" dirty="0">
                 <a:solidFill>
-                  <a:srgbClr val="FF6A4D"/>
+                  <a:srgbClr val="3DD6A0"/>
                 </a:solidFill>
                 <a:latin typeface="Be Vietnam Pro" pitchFamily="34" charset="0"/>
                 <a:ea typeface="Be Vietnam Pro" pitchFamily="34" charset="-122"/>
@@ -13298,7 +13298,7 @@
             <a:r>
               <a:rPr lang="en-US" sz="1950" b="1" spc="227" kern="0" dirty="0">
                 <a:solidFill>
-                  <a:srgbClr val="FF6A4D"/>
+                  <a:srgbClr val="3DD6A0"/>
                 </a:solidFill>
                 <a:latin typeface="Be Vietnam Pro" pitchFamily="34" charset="0"/>
                 <a:ea typeface="Be Vietnam Pro" pitchFamily="34" charset="-122"/>
@@ -13808,7 +13808,7 @@
           </a:solidFill>
           <a:ln w="28575">
             <a:solidFill>
-              <a:srgbClr val="FF6A4D"/>
+              <a:srgbClr val="3DD6A0"/>
             </a:solidFill>
             <a:prstDash val="solid"/>
           </a:ln>
@@ -13841,7 +13841,7 @@
             <a:r>
               <a:rPr lang="en-US" sz="1800" b="1" spc="161" kern="0" dirty="0">
                 <a:solidFill>
-                  <a:srgbClr val="FF6A4D"/>
+                  <a:srgbClr val="3DD6A0"/>
                 </a:solidFill>
                 <a:latin typeface="Be Vietnam Pro" pitchFamily="34" charset="0"/>
                 <a:ea typeface="Be Vietnam Pro" pitchFamily="34" charset="-122"/>
@@ -13852,7 +13852,7 @@
             <a:r>
               <a:rPr lang="en-US" sz="1800" b="1" spc="207" kern="0" dirty="0">
                 <a:solidFill>
-                  <a:srgbClr val="FF6A4D"/>
+                  <a:srgbClr val="3DD6A0"/>
                 </a:solidFill>
                 <a:latin typeface="Be Vietnam Pro" pitchFamily="34" charset="0"/>
                 <a:ea typeface="Be Vietnam Pro" pitchFamily="34" charset="-122"/>
@@ -13863,7 +13863,7 @@
             <a:r>
               <a:rPr lang="en-US" sz="1800" b="1" spc="188" kern="0" dirty="0">
                 <a:solidFill>
-                  <a:srgbClr val="FF6A4D"/>
+                  <a:srgbClr val="3DD6A0"/>
                 </a:solidFill>
                 <a:latin typeface="Be Vietnam Pro" pitchFamily="34" charset="0"/>
                 <a:ea typeface="Be Vietnam Pro" pitchFamily="34" charset="-122"/>
@@ -14010,7 +14010,7 @@
             <a:r>
               <a:rPr lang="en-US" sz="1800" b="1" spc="216" kern="0" dirty="0">
                 <a:solidFill>
-                  <a:srgbClr val="E8472B"/>
+                  <a:srgbClr val="0F766E"/>
                 </a:solidFill>
                 <a:latin typeface="Be Vietnam Pro" pitchFamily="34" charset="0"/>
                 <a:ea typeface="Be Vietnam Pro" pitchFamily="34" charset="-122"/>
@@ -14021,7 +14021,7 @@
             <a:r>
               <a:rPr lang="en-US" sz="1800" b="1" spc="201" kern="0" dirty="0">
                 <a:solidFill>
-                  <a:srgbClr val="E8472B"/>
+                  <a:srgbClr val="0F766E"/>
                 </a:solidFill>
                 <a:latin typeface="Be Vietnam Pro" pitchFamily="34" charset="0"/>
                 <a:ea typeface="Be Vietnam Pro" pitchFamily="34" charset="-122"/>
@@ -14032,7 +14032,7 @@
             <a:r>
               <a:rPr lang="en-US" sz="1800" b="1" spc="225" kern="0" dirty="0">
                 <a:solidFill>
-                  <a:srgbClr val="E8472B"/>
+                  <a:srgbClr val="0F766E"/>
                 </a:solidFill>
                 <a:latin typeface="Be Vietnam Pro" pitchFamily="34" charset="0"/>
                 <a:ea typeface="Be Vietnam Pro" pitchFamily="34" charset="-122"/>

</xml_diff>